<commit_message>
Add GitHub link to presentation
</commit_message>
<xml_diff>
--- a/ADK_Ollama_Presentation.pptx
+++ b/ADK_Ollama_Presentation.pptx
@@ -3349,6 +3349,41 @@
         </p:nvSpPr>
         <p:spPr>
           <a:xfrm>
+            <a:off x="457200" y="2514600"/>
+            <a:ext cx="8229600" cy="365760"/>
+          </a:xfrm>
+          <a:prstGeom prst="rect">
+            <a:avLst/>
+          </a:prstGeom>
+          <a:noFill/>
+        </p:spPr>
+        <p:txBody>
+          <a:bodyPr wrap="square">
+            <a:spAutoFit/>
+          </a:bodyPr>
+          <a:lstStyle/>
+          <a:p>
+            <a:pPr algn="ctr"/>
+            <a:r>
+              <a:rPr sz="1200" b="0">
+                <a:solidFill>
+                  <a:srgbClr val="06B6D4"/>
+                </a:solidFill>
+                <a:latin typeface="Calibri"/>
+              </a:rPr>
+              <a:t>https://github.com/bereket-s/ADK-ollama</a:t>
+            </a:r>
+          </a:p>
+        </p:txBody>
+      </p:sp>
+      <p:sp>
+        <p:nvSpPr>
+          <p:cNvPr id="9" name="TextBox 8"/>
+          <p:cNvSpPr txBox="1"/>
+          <p:nvPr/>
+        </p:nvSpPr>
+        <p:spPr>
+          <a:xfrm>
             <a:off x="457200" y="4389120"/>
             <a:ext cx="8229600" cy="365760"/>
           </a:xfrm>
@@ -3378,7 +3413,7 @@
       </p:sp>
       <p:sp>
         <p:nvSpPr>
-          <p:cNvPr id="9" name="Rectangle 8"/>
+          <p:cNvPr id="10" name="Rectangle 9"/>
           <p:cNvSpPr/>
           <p:nvPr/>
         </p:nvSpPr>
@@ -3421,7 +3456,7 @@
       </p:sp>
       <p:sp>
         <p:nvSpPr>
-          <p:cNvPr id="10" name="TextBox 9"/>
+          <p:cNvPr id="11" name="TextBox 10"/>
           <p:cNvSpPr txBox="1"/>
           <p:nvPr/>
         </p:nvSpPr>
@@ -3456,7 +3491,7 @@
       </p:sp>
       <p:sp>
         <p:nvSpPr>
-          <p:cNvPr id="11" name="Rectangle 10"/>
+          <p:cNvPr id="12" name="Rectangle 11"/>
           <p:cNvSpPr/>
           <p:nvPr/>
         </p:nvSpPr>
@@ -3499,7 +3534,7 @@
       </p:sp>
       <p:sp>
         <p:nvSpPr>
-          <p:cNvPr id="12" name="TextBox 11"/>
+          <p:cNvPr id="13" name="TextBox 12"/>
           <p:cNvSpPr txBox="1"/>
           <p:nvPr/>
         </p:nvSpPr>
@@ -3534,7 +3569,7 @@
       </p:sp>
       <p:sp>
         <p:nvSpPr>
-          <p:cNvPr id="13" name="Rectangle 12"/>
+          <p:cNvPr id="14" name="Rectangle 13"/>
           <p:cNvSpPr/>
           <p:nvPr/>
         </p:nvSpPr>
@@ -3577,7 +3612,7 @@
       </p:sp>
       <p:sp>
         <p:nvSpPr>
-          <p:cNvPr id="14" name="TextBox 13"/>
+          <p:cNvPr id="15" name="TextBox 14"/>
           <p:cNvSpPr txBox="1"/>
           <p:nvPr/>
         </p:nvSpPr>
@@ -3612,7 +3647,7 @@
       </p:sp>
       <p:sp>
         <p:nvSpPr>
-          <p:cNvPr id="15" name="Rectangle 14"/>
+          <p:cNvPr id="16" name="Rectangle 15"/>
           <p:cNvSpPr/>
           <p:nvPr/>
         </p:nvSpPr>
@@ -3655,7 +3690,7 @@
       </p:sp>
       <p:sp>
         <p:nvSpPr>
-          <p:cNvPr id="16" name="TextBox 15"/>
+          <p:cNvPr id="17" name="TextBox 16"/>
           <p:cNvSpPr txBox="1"/>
           <p:nvPr/>
         </p:nvSpPr>
@@ -6142,6 +6177,41 @@
       <p:sp>
         <p:nvSpPr>
           <p:cNvPr id="18" name="TextBox 17"/>
+          <p:cNvSpPr txBox="1"/>
+          <p:nvPr/>
+        </p:nvSpPr>
+        <p:spPr>
+          <a:xfrm>
+            <a:off x="365760" y="4206240"/>
+            <a:ext cx="8412480" cy="365760"/>
+          </a:xfrm>
+          <a:prstGeom prst="rect">
+            <a:avLst/>
+          </a:prstGeom>
+          <a:noFill/>
+        </p:spPr>
+        <p:txBody>
+          <a:bodyPr wrap="square">
+            <a:spAutoFit/>
+          </a:bodyPr>
+          <a:lstStyle/>
+          <a:p>
+            <a:pPr algn="ctr"/>
+            <a:r>
+              <a:rPr sz="1200" b="1">
+                <a:solidFill>
+                  <a:srgbClr val="06B6D4"/>
+                </a:solidFill>
+                <a:latin typeface="Calibri"/>
+              </a:rPr>
+              <a:t>GitHub: https://github.com/bereket-s/ADK-ollama</a:t>
+            </a:r>
+          </a:p>
+        </p:txBody>
+      </p:sp>
+      <p:sp>
+        <p:nvSpPr>
+          <p:cNvPr id="19" name="TextBox 18"/>
           <p:cNvSpPr txBox="1"/>
           <p:nvPr/>
         </p:nvSpPr>

</xml_diff>